<commit_message>
Add complete portfolio deck with Meridian and refresh highlights
Add the complete 181-slide case study deck: all original case studies,
Meridian, the FinViz competitive slide, and the Lead UX designer title.
Refresh the highlights deck and PDF with the standards and teams slide.

Co-Authored-By: Claude Haiku 5.5 <noreply@anthropic.com>
</commit_message>
<xml_diff>
--- a/Portfolio-Highlights.pptx
+++ b/Portfolio-Highlights.pptx
@@ -17,9 +17,10 @@
     <p:sldId id="265" r:id="rId11"/>
     <p:sldId id="266" r:id="rId12"/>
     <p:sldId id="267" r:id="rId13"/>
+    <p:sldId id="268" r:id="rId14"/>
   </p:sldIdLst>
   <p:notesMasterIdLst>
-    <p:notesMasterId r:id="rId14"/>
+    <p:notesMasterId r:id="rId15"/>
   </p:notesMasterIdLst>
   <p:sldSz cx="13004597" cy="9753905"/>
   <p:notesSz cx="9753905" cy="13004597"/>
@@ -777,7 +778,7 @@
           <a:p>
             <a:r>
               <a:rPr lang="en-US" dirty="0"/>
-              <a:t>Close on the next step you would take with this team in the first two weeks.</a:t>
+              <a:t>Be exact: accessibility is specified in both design systems but has not been audited. Handoff is tokens and documentation, not a verified sync. Team work is reviews and open requests, not a record of day-to-day collaboration.</a:t>
             </a:r>
             <a:endParaRPr lang="en-US" dirty="0"/>
           </a:p>
@@ -801,6 +802,94 @@
             <a:fld id="{F7021451-1387-4CA6-816F-3879F97B5CBC}" type="slidenum">
               <a:rPr lang="en-US"/>
               <a:t>12</a:t>
+            </a:fld>
+            <a:endParaRPr lang="en-US"/>
+          </a:p>
+        </p:txBody>
+      </p:sp>
+    </p:spTree>
+    <p:extLst>
+      <p:ext uri="{BB962C8B-B14F-4D97-AF65-F5344CB8AC3E}">
+        <p14:creationId xmlns:p14="http://schemas.microsoft.com/office/powerpoint/2010/main" val="1024086991"/>
+      </p:ext>
+    </p:extLst>
+  </p:cSld>
+  <p:clrMapOvr>
+    <a:masterClrMapping/>
+  </p:clrMapOvr>
+</p:notes>
+</file>
+
+<file path=ppt/notesSlides/notesSlide13.xml><?xml version="1.0" encoding="utf-8"?>
+<p:notes xmlns:a="http://schemas.openxmlformats.org/drawingml/2006/main" xmlns:r="http://schemas.openxmlformats.org/officeDocument/2006/relationships" xmlns:p="http://schemas.openxmlformats.org/presentationml/2006/main">
+  <p:cSld>
+    <p:spTree>
+      <p:nvGrpSpPr>
+        <p:cNvPr id="1" name=""/>
+        <p:cNvGrpSpPr/>
+        <p:nvPr/>
+      </p:nvGrpSpPr>
+      <p:grpSpPr>
+        <a:xfrm>
+          <a:off x="0" y="0"/>
+          <a:ext cx="0" cy="0"/>
+          <a:chOff x="0" y="0"/>
+          <a:chExt cx="0" cy="0"/>
+        </a:xfrm>
+      </p:grpSpPr>
+      <p:sp>
+        <p:nvSpPr>
+          <p:cNvPr id="2" name="Slide Image Placeholder 1"/>
+          <p:cNvSpPr>
+            <a:spLocks noGrp="1" noRot="1" noChangeAspect="1"/>
+          </p:cNvSpPr>
+          <p:nvPr>
+            <p:ph type="sldImg"/>
+          </p:nvPr>
+        </p:nvSpPr>
+        <p:spPr/>
+      </p:sp>
+      <p:sp>
+        <p:nvSpPr>
+          <p:cNvPr id="3" name="Notes Placeholder 2"/>
+          <p:cNvSpPr>
+            <a:spLocks noGrp="1"/>
+          </p:cNvSpPr>
+          <p:nvPr>
+            <p:ph type="body" idx="1"/>
+          </p:nvPr>
+        </p:nvSpPr>
+        <p:spPr/>
+        <p:txBody>
+          <a:bodyPr/>
+          <a:lstStyle/>
+          <a:p>
+            <a:r>
+              <a:rPr lang="en-US" dirty="0"/>
+              <a:t>Close on the next step you would take with this team in the first two weeks.</a:t>
+            </a:r>
+            <a:endParaRPr lang="en-US" dirty="0"/>
+          </a:p>
+        </p:txBody>
+      </p:sp>
+      <p:sp>
+        <p:nvSpPr>
+          <p:cNvPr id="4" name="Slide Number Placeholder 3"/>
+          <p:cNvSpPr>
+            <a:spLocks noGrp="1"/>
+          </p:cNvSpPr>
+          <p:nvPr>
+            <p:ph type="sldNum" sz="quarter" idx="10"/>
+          </p:nvPr>
+        </p:nvSpPr>
+        <p:spPr/>
+        <p:txBody>
+          <a:bodyPr/>
+          <a:lstStyle/>
+          <a:p>
+            <a:fld id="{F7021451-1387-4CA6-816F-3879F97B5CBC}" type="slidenum">
+              <a:rPr lang="en-US"/>
+              <a:t>13</a:t>
             </a:fld>
             <a:endParaRPr lang="en-US"/>
           </a:p>
@@ -4123,6 +4212,512 @@
                 <a:ea typeface="Helvetica Neue" pitchFamily="34" charset="-122"/>
                 <a:cs typeface="Helvetica Neue" pitchFamily="34" charset="-120"/>
               </a:rPr>
+              <a:t>Standards and teams</a:t>
+            </a:r>
+            <a:endParaRPr lang="en-US" sz="1422" dirty="0"/>
+          </a:p>
+        </p:txBody>
+      </p:sp>
+      <p:sp>
+        <p:nvSpPr>
+          <p:cNvPr id="3" name="Text 1"/>
+          <p:cNvSpPr txBox="1"/>
+          <p:nvPr/>
+        </p:nvSpPr>
+        <p:spPr>
+          <a:xfrm>
+            <a:off x="457200" y="914400"/>
+            <a:ext cx="12070080" cy="594360"/>
+          </a:xfrm>
+          <a:prstGeom prst="rect">
+            <a:avLst/>
+          </a:prstGeom>
+          <a:noFill/>
+          <a:ln/>
+        </p:spPr>
+        <p:txBody>
+          <a:bodyPr wrap="square" lIns="0" tIns="0" rIns="0" bIns="0" rtlCol="0" anchor="t"/>
+          <a:lstStyle/>
+          <a:p>
+            <a:pPr indent="0" marL="0">
+              <a:buNone/>
+            </a:pPr>
+            <a:r>
+              <a:rPr lang="en-US" sz="3200" dirty="0">
+                <a:solidFill>
+                  <a:srgbClr val="1F1F1F"/>
+                </a:solidFill>
+                <a:latin typeface="Helvetica Neue Light" pitchFamily="34" charset="0"/>
+                <a:ea typeface="Helvetica Neue Light" pitchFamily="34" charset="-122"/>
+                <a:cs typeface="Helvetica Neue Light" pitchFamily="34" charset="-120"/>
+              </a:rPr>
+              <a:t>Accessibility, handoff, and working with teams</a:t>
+            </a:r>
+            <a:endParaRPr lang="en-US" sz="3200" dirty="0"/>
+          </a:p>
+        </p:txBody>
+      </p:sp>
+      <p:sp>
+        <p:nvSpPr>
+          <p:cNvPr id="4" name="Text 2"/>
+          <p:cNvSpPr txBox="1"/>
+          <p:nvPr/>
+        </p:nvSpPr>
+        <p:spPr>
+          <a:xfrm>
+            <a:off x="457200" y="1554480"/>
+            <a:ext cx="12070080" cy="365760"/>
+          </a:xfrm>
+          <a:prstGeom prst="rect">
+            <a:avLst/>
+          </a:prstGeom>
+          <a:noFill/>
+          <a:ln/>
+        </p:spPr>
+        <p:txBody>
+          <a:bodyPr wrap="square" lIns="0" tIns="0" rIns="0" bIns="0" rtlCol="0" anchor="t"/>
+          <a:lstStyle/>
+          <a:p>
+            <a:pPr indent="0" marL="0">
+              <a:buNone/>
+            </a:pPr>
+            <a:r>
+              <a:rPr lang="en-US" sz="1636" dirty="0">
+                <a:solidFill>
+                  <a:srgbClr val="595959"/>
+                </a:solidFill>
+                <a:latin typeface="Helvetica Neue Light" pitchFamily="34" charset="0"/>
+                <a:ea typeface="Helvetica Neue Light" pitchFamily="34" charset="-122"/>
+                <a:cs typeface="Helvetica Neue Light" pitchFamily="34" charset="-120"/>
+              </a:rPr>
+              <a:t>What is specified, what is in place, and what has not been checked yet.</a:t>
+            </a:r>
+            <a:endParaRPr lang="en-US" sz="1636" dirty="0"/>
+          </a:p>
+        </p:txBody>
+      </p:sp>
+      <p:pic>
+        <p:nvPicPr>
+          <p:cNvPr id="5" name="Image 0" descr="/tmp/meridian-deck/img/band-footer.png">    </p:cNvPr>
+          <p:cNvPicPr>
+            <a:picLocks noChangeAspect="1"/>
+          </p:cNvPicPr>
+          <p:nvPr/>
+        </p:nvPicPr>
+        <p:blipFill>
+          <a:blip r:embed="rId1"/>
+          <a:stretch>
+            <a:fillRect/>
+          </a:stretch>
+        </p:blipFill>
+        <p:spPr>
+          <a:xfrm>
+            <a:off x="0" y="9281160"/>
+            <a:ext cx="13004597" cy="466344"/>
+          </a:xfrm>
+          <a:prstGeom prst="rect">
+            <a:avLst/>
+          </a:prstGeom>
+        </p:spPr>
+      </p:pic>
+      <p:sp>
+        <p:nvSpPr>
+          <p:cNvPr id="7" name="Shape 3"/>
+          <p:cNvSpPr/>
+          <p:nvPr/>
+        </p:nvSpPr>
+        <p:spPr>
+          <a:xfrm>
+            <a:off x="457200" y="2560320"/>
+            <a:ext cx="12070080" cy="1920240"/>
+          </a:xfrm>
+          <a:prstGeom prst="rect">
+            <a:avLst/>
+          </a:prstGeom>
+          <a:solidFill>
+            <a:srgbClr val="FFFFFF"/>
+          </a:solidFill>
+          <a:ln w="12700">
+            <a:solidFill>
+              <a:srgbClr val="E2E2E2"/>
+            </a:solidFill>
+            <a:prstDash val="solid"/>
+          </a:ln>
+        </p:spPr>
+      </p:sp>
+      <p:sp>
+        <p:nvSpPr>
+          <p:cNvPr id="8" name="Text 4"/>
+          <p:cNvSpPr txBox="1"/>
+          <p:nvPr/>
+        </p:nvSpPr>
+        <p:spPr>
+          <a:xfrm>
+            <a:off x="731520" y="2761488"/>
+            <a:ext cx="11521440" cy="274320"/>
+          </a:xfrm>
+          <a:prstGeom prst="rect">
+            <a:avLst/>
+          </a:prstGeom>
+          <a:noFill/>
+          <a:ln/>
+        </p:spPr>
+        <p:txBody>
+          <a:bodyPr wrap="square" lIns="0" tIns="0" rIns="0" bIns="0" rtlCol="0" anchor="t"/>
+          <a:lstStyle/>
+          <a:p>
+            <a:pPr indent="0" marL="0">
+              <a:buNone/>
+            </a:pPr>
+            <a:r>
+              <a:rPr lang="en-US" sz="1280" b="1" spc="100" kern="0" dirty="0">
+                <a:solidFill>
+                  <a:srgbClr val="00868B"/>
+                </a:solidFill>
+                <a:latin typeface="Helvetica Neue" pitchFamily="34" charset="0"/>
+                <a:ea typeface="Helvetica Neue" pitchFamily="34" charset="-122"/>
+                <a:cs typeface="Helvetica Neue" pitchFamily="34" charset="-120"/>
+              </a:rPr>
+              <a:t>ACCESSIBILITY</a:t>
+            </a:r>
+            <a:endParaRPr lang="en-US" sz="1280" dirty="0"/>
+          </a:p>
+        </p:txBody>
+      </p:sp>
+      <p:sp>
+        <p:nvSpPr>
+          <p:cNvPr id="9" name="Text 5"/>
+          <p:cNvSpPr txBox="1"/>
+          <p:nvPr/>
+        </p:nvSpPr>
+        <p:spPr>
+          <a:xfrm>
+            <a:off x="731520" y="3108960"/>
+            <a:ext cx="11521440" cy="1234440"/>
+          </a:xfrm>
+          <a:prstGeom prst="rect">
+            <a:avLst/>
+          </a:prstGeom>
+          <a:noFill/>
+          <a:ln/>
+        </p:spPr>
+        <p:txBody>
+          <a:bodyPr wrap="square" lIns="0" tIns="0" rIns="0" bIns="0" rtlCol="0" anchor="t"/>
+          <a:lstStyle/>
+          <a:p>
+            <a:pPr indent="0" marL="0">
+              <a:buNone/>
+            </a:pPr>
+            <a:r>
+              <a:rPr lang="en-US" sz="1700" dirty="0">
+                <a:solidFill>
+                  <a:srgbClr val="1F1F1F"/>
+                </a:solidFill>
+                <a:latin typeface="Helvetica Neue Light" pitchFamily="34" charset="0"/>
+                <a:ea typeface="Helvetica Neue Light" pitchFamily="34" charset="-122"/>
+                <a:cs typeface="Helvetica Neue Light" pitchFamily="34" charset="-120"/>
+              </a:rPr>
+              <a:t>Specified: WCAG 2.2 AA in the FinViz design system (4.5:1 text contrast, 24px targets), and WCAG AA with ARIA labels in Meridian. Not audited.</a:t>
+            </a:r>
+            <a:endParaRPr lang="en-US" sz="1700" dirty="0"/>
+          </a:p>
+        </p:txBody>
+      </p:sp>
+      <p:sp>
+        <p:nvSpPr>
+          <p:cNvPr id="10" name="Shape 6"/>
+          <p:cNvSpPr/>
+          <p:nvPr/>
+        </p:nvSpPr>
+        <p:spPr>
+          <a:xfrm>
+            <a:off x="457200" y="4754880"/>
+            <a:ext cx="12070080" cy="1920240"/>
+          </a:xfrm>
+          <a:prstGeom prst="rect">
+            <a:avLst/>
+          </a:prstGeom>
+          <a:solidFill>
+            <a:srgbClr val="FFFFFF"/>
+          </a:solidFill>
+          <a:ln w="12700">
+            <a:solidFill>
+              <a:srgbClr val="E2E2E2"/>
+            </a:solidFill>
+            <a:prstDash val="solid"/>
+          </a:ln>
+        </p:spPr>
+      </p:sp>
+      <p:sp>
+        <p:nvSpPr>
+          <p:cNvPr id="11" name="Text 7"/>
+          <p:cNvSpPr txBox="1"/>
+          <p:nvPr/>
+        </p:nvSpPr>
+        <p:spPr>
+          <a:xfrm>
+            <a:off x="731520" y="4956048"/>
+            <a:ext cx="11521440" cy="274320"/>
+          </a:xfrm>
+          <a:prstGeom prst="rect">
+            <a:avLst/>
+          </a:prstGeom>
+          <a:noFill/>
+          <a:ln/>
+        </p:spPr>
+        <p:txBody>
+          <a:bodyPr wrap="square" lIns="0" tIns="0" rIns="0" bIns="0" rtlCol="0" anchor="t"/>
+          <a:lstStyle/>
+          <a:p>
+            <a:pPr indent="0" marL="0">
+              <a:buNone/>
+            </a:pPr>
+            <a:r>
+              <a:rPr lang="en-US" sz="1280" b="1" spc="100" kern="0" dirty="0">
+                <a:solidFill>
+                  <a:srgbClr val="5B3F96"/>
+                </a:solidFill>
+                <a:latin typeface="Helvetica Neue" pitchFamily="34" charset="0"/>
+                <a:ea typeface="Helvetica Neue" pitchFamily="34" charset="-122"/>
+                <a:cs typeface="Helvetica Neue" pitchFamily="34" charset="-120"/>
+              </a:rPr>
+              <a:t>HANDOFF</a:t>
+            </a:r>
+            <a:endParaRPr lang="en-US" sz="1280" dirty="0"/>
+          </a:p>
+        </p:txBody>
+      </p:sp>
+      <p:sp>
+        <p:nvSpPr>
+          <p:cNvPr id="12" name="Text 8"/>
+          <p:cNvSpPr txBox="1"/>
+          <p:nvPr/>
+        </p:nvSpPr>
+        <p:spPr>
+          <a:xfrm>
+            <a:off x="731520" y="5303520"/>
+            <a:ext cx="11521440" cy="1234440"/>
+          </a:xfrm>
+          <a:prstGeom prst="rect">
+            <a:avLst/>
+          </a:prstGeom>
+          <a:noFill/>
+          <a:ln/>
+        </p:spPr>
+        <p:txBody>
+          <a:bodyPr wrap="square" lIns="0" tIns="0" rIns="0" bIns="0" rtlCol="0" anchor="t"/>
+          <a:lstStyle/>
+          <a:p>
+            <a:pPr indent="0" marL="0">
+              <a:buNone/>
+            </a:pPr>
+            <a:r>
+              <a:rPr lang="en-US" sz="1700" dirty="0">
+                <a:solidFill>
+                  <a:srgbClr val="1F1F1F"/>
+                </a:solidFill>
+                <a:latin typeface="Helvetica Neue Light" pitchFamily="34" charset="0"/>
+                <a:ea typeface="Helvetica Neue Light" pitchFamily="34" charset="-122"/>
+                <a:cs typeface="Helvetica Neue Light" pitchFamily="34" charset="-120"/>
+              </a:rPr>
+              <a:t>In place: colors and spacing are defined as tokens in the design system, and the Figma file uses the same navy and cyan values. Not verified: a live sync between Figma and SwiftUI.</a:t>
+            </a:r>
+            <a:endParaRPr lang="en-US" sz="1700" dirty="0"/>
+          </a:p>
+        </p:txBody>
+      </p:sp>
+      <p:sp>
+        <p:nvSpPr>
+          <p:cNvPr id="13" name="Shape 9"/>
+          <p:cNvSpPr/>
+          <p:nvPr/>
+        </p:nvSpPr>
+        <p:spPr>
+          <a:xfrm>
+            <a:off x="457200" y="6949440"/>
+            <a:ext cx="12070080" cy="1920240"/>
+          </a:xfrm>
+          <a:prstGeom prst="rect">
+            <a:avLst/>
+          </a:prstGeom>
+          <a:solidFill>
+            <a:srgbClr val="FFFFFF"/>
+          </a:solidFill>
+          <a:ln w="12700">
+            <a:solidFill>
+              <a:srgbClr val="E2E2E2"/>
+            </a:solidFill>
+            <a:prstDash val="solid"/>
+          </a:ln>
+        </p:spPr>
+      </p:sp>
+      <p:sp>
+        <p:nvSpPr>
+          <p:cNvPr id="14" name="Text 10"/>
+          <p:cNvSpPr txBox="1"/>
+          <p:nvPr/>
+        </p:nvSpPr>
+        <p:spPr>
+          <a:xfrm>
+            <a:off x="731520" y="7150608"/>
+            <a:ext cx="11521440" cy="274320"/>
+          </a:xfrm>
+          <a:prstGeom prst="rect">
+            <a:avLst/>
+          </a:prstGeom>
+          <a:noFill/>
+          <a:ln/>
+        </p:spPr>
+        <p:txBody>
+          <a:bodyPr wrap="square" lIns="0" tIns="0" rIns="0" bIns="0" rtlCol="0" anchor="t"/>
+          <a:lstStyle/>
+          <a:p>
+            <a:pPr indent="0" marL="0">
+              <a:buNone/>
+            </a:pPr>
+            <a:r>
+              <a:rPr lang="en-US" sz="1280" b="1" spc="100" kern="0" dirty="0">
+                <a:solidFill>
+                  <a:srgbClr val="C45A35"/>
+                </a:solidFill>
+                <a:latin typeface="Helvetica Neue" pitchFamily="34" charset="0"/>
+                <a:ea typeface="Helvetica Neue" pitchFamily="34" charset="-122"/>
+                <a:cs typeface="Helvetica Neue" pitchFamily="34" charset="-120"/>
+              </a:rPr>
+              <a:t>TEAMS AND COMPLIANCE</a:t>
+            </a:r>
+            <a:endParaRPr lang="en-US" sz="1280" dirty="0"/>
+          </a:p>
+        </p:txBody>
+      </p:sp>
+      <p:sp>
+        <p:nvSpPr>
+          <p:cNvPr id="15" name="Text 11"/>
+          <p:cNvSpPr txBox="1"/>
+          <p:nvPr/>
+        </p:nvSpPr>
+        <p:spPr>
+          <a:xfrm>
+            <a:off x="731520" y="7498080"/>
+            <a:ext cx="11521440" cy="1234440"/>
+          </a:xfrm>
+          <a:prstGeom prst="rect">
+            <a:avLst/>
+          </a:prstGeom>
+          <a:noFill/>
+          <a:ln/>
+        </p:spPr>
+        <p:txBody>
+          <a:bodyPr wrap="square" lIns="0" tIns="0" rIns="0" bIns="0" rtlCol="0" anchor="t"/>
+          <a:lstStyle/>
+          <a:p>
+            <a:pPr indent="0" marL="0">
+              <a:buNone/>
+            </a:pPr>
+            <a:r>
+              <a:rPr lang="en-US" sz="1700" dirty="0">
+                <a:solidFill>
+                  <a:srgbClr val="1F1F1F"/>
+                </a:solidFill>
+                <a:latin typeface="Helvetica Neue Light" pitchFamily="34" charset="0"/>
+                <a:ea typeface="Helvetica Neue Light" pitchFamily="34" charset="-122"/>
+                <a:cs typeface="Helvetica Neue Light" pitchFamily="34" charset="-120"/>
+              </a:rPr>
+              <a:t>Reviews: four reviewers commented on the FinViz boards on 30 Sept. Open: the advice line is waiting on compliance review. Day-to-day work with PMs and engineers is not documented in the project files.</a:t>
+            </a:r>
+            <a:endParaRPr lang="en-US" sz="1700" dirty="0"/>
+          </a:p>
+        </p:txBody>
+      </p:sp>
+      <p:pic>
+        <p:nvPicPr>
+          <p:cNvPr id="16" name="Image 1" descr="/tmp/meridian-deck/img/band-footer.png">    </p:cNvPr>
+          <p:cNvPicPr>
+            <a:picLocks noChangeAspect="1"/>
+          </p:cNvPicPr>
+          <p:nvPr/>
+        </p:nvPicPr>
+        <p:blipFill>
+          <a:blip r:embed="rId2"/>
+          <a:stretch>
+            <a:fillRect/>
+          </a:stretch>
+        </p:blipFill>
+        <p:spPr>
+          <a:xfrm>
+            <a:off x="0" y="9281160"/>
+            <a:ext cx="13004597" cy="466344"/>
+          </a:xfrm>
+          <a:prstGeom prst="rect">
+            <a:avLst/>
+          </a:prstGeom>
+        </p:spPr>
+      </p:pic>
+    </p:spTree>
+  </p:cSld>
+  <p:clrMapOvr>
+    <a:masterClrMapping/>
+  </p:clrMapOvr>
+</p:sld>
+</file>
+
+<file path=ppt/slides/slide13.xml><?xml version="1.0" encoding="utf-8"?>
+<p:sld xmlns:a="http://schemas.openxmlformats.org/drawingml/2006/main" xmlns:r="http://schemas.openxmlformats.org/officeDocument/2006/relationships" xmlns:p="http://schemas.openxmlformats.org/presentationml/2006/main">
+  <p:cSld name="Slide 13">
+    <p:bg>
+      <p:bgPr>
+        <a:solidFill>
+          <a:srgbClr val="FFFFFF"/>
+        </a:solidFill>
+      </p:bgPr>
+    </p:bg>
+    <p:spTree>
+      <p:nvGrpSpPr>
+        <p:cNvPr id="1" name=""/>
+        <p:cNvGrpSpPr/>
+        <p:nvPr/>
+      </p:nvGrpSpPr>
+      <p:grpSpPr>
+        <a:xfrm>
+          <a:off x="0" y="0"/>
+          <a:ext cx="0" cy="0"/>
+          <a:chOff x="0" y="0"/>
+          <a:chExt cx="0" cy="0"/>
+        </a:xfrm>
+      </p:grpSpPr>
+      <p:sp>
+        <p:nvSpPr>
+          <p:cNvPr id="2" name="Text 0"/>
+          <p:cNvSpPr txBox="1"/>
+          <p:nvPr/>
+        </p:nvSpPr>
+        <p:spPr>
+          <a:xfrm>
+            <a:off x="457200" y="393192"/>
+            <a:ext cx="10424160" cy="274320"/>
+          </a:xfrm>
+          <a:prstGeom prst="rect">
+            <a:avLst/>
+          </a:prstGeom>
+          <a:noFill/>
+          <a:ln/>
+        </p:spPr>
+        <p:txBody>
+          <a:bodyPr wrap="square" lIns="0" tIns="0" rIns="0" bIns="0" rtlCol="0" anchor="t"/>
+          <a:lstStyle/>
+          <a:p>
+            <a:pPr indent="0" marL="0">
+              <a:buNone/>
+            </a:pPr>
+            <a:r>
+              <a:rPr lang="en-US" sz="1422" dirty="0">
+                <a:solidFill>
+                  <a:srgbClr val="1F1F1F"/>
+                </a:solidFill>
+                <a:latin typeface="Helvetica Neue" pitchFamily="34" charset="0"/>
+                <a:ea typeface="Helvetica Neue" pitchFamily="34" charset="-122"/>
+                <a:cs typeface="Helvetica Neue" pitchFamily="34" charset="-120"/>
+              </a:rPr>
               <a:t>Next steps</a:t>
             </a:r>
             <a:endParaRPr lang="en-US" sz="1422" dirty="0"/>

</xml_diff>

<commit_message>
Update portfolio decks with agent experience section
Rebuild the complete (187 slides), combined (143), and core (48) decks with the
Meridian agent experience section. Refresh the highlights deck and PDF with an
agent slide and renumbered agenda links.

Co-Authored-By: Claude Haiku 5.5 <noreply@anthropic.com>
</commit_message>
<xml_diff>
--- a/Portfolio-Highlights.pptx
+++ b/Portfolio-Highlights.pptx
@@ -18,9 +18,10 @@
     <p:sldId id="266" r:id="rId12"/>
     <p:sldId id="267" r:id="rId13"/>
     <p:sldId id="268" r:id="rId14"/>
+    <p:sldId id="269" r:id="rId15"/>
   </p:sldIdLst>
   <p:notesMasterIdLst>
-    <p:notesMasterId r:id="rId15"/>
+    <p:notesMasterId r:id="rId16"/>
   </p:notesMasterIdLst>
   <p:sldSz cx="13004597" cy="9753905"/>
   <p:notesSz cx="9753905" cy="13004597"/>
@@ -866,7 +867,7 @@
           <a:p>
             <a:r>
               <a:rPr lang="en-US" dirty="0"/>
-              <a:t>Close on the next step you would take with this team in the first two weeks.</a:t>
+              <a:t>Name the breakdowns first: outputs without reasoning, all-or-nothing Adapt, no learning loop, advice wording in conflict, and lost context. Then the four concepts. Be clear that the learning loop is a hypothesis, and the advice boundary is pending compliance.</a:t>
             </a:r>
             <a:endParaRPr lang="en-US" dirty="0"/>
           </a:p>
@@ -890,6 +891,94 @@
             <a:fld id="{F7021451-1387-4CA6-816F-3879F97B5CBC}" type="slidenum">
               <a:rPr lang="en-US"/>
               <a:t>13</a:t>
+            </a:fld>
+            <a:endParaRPr lang="en-US"/>
+          </a:p>
+        </p:txBody>
+      </p:sp>
+    </p:spTree>
+    <p:extLst>
+      <p:ext uri="{BB962C8B-B14F-4D97-AF65-F5344CB8AC3E}">
+        <p14:creationId xmlns:p14="http://schemas.microsoft.com/office/powerpoint/2010/main" val="1024086991"/>
+      </p:ext>
+    </p:extLst>
+  </p:cSld>
+  <p:clrMapOvr>
+    <a:masterClrMapping/>
+  </p:clrMapOvr>
+</p:notes>
+</file>
+
+<file path=ppt/notesSlides/notesSlide14.xml><?xml version="1.0" encoding="utf-8"?>
+<p:notes xmlns:a="http://schemas.openxmlformats.org/drawingml/2006/main" xmlns:r="http://schemas.openxmlformats.org/officeDocument/2006/relationships" xmlns:p="http://schemas.openxmlformats.org/presentationml/2006/main">
+  <p:cSld>
+    <p:spTree>
+      <p:nvGrpSpPr>
+        <p:cNvPr id="1" name=""/>
+        <p:cNvGrpSpPr/>
+        <p:nvPr/>
+      </p:nvGrpSpPr>
+      <p:grpSpPr>
+        <a:xfrm>
+          <a:off x="0" y="0"/>
+          <a:ext cx="0" cy="0"/>
+          <a:chOff x="0" y="0"/>
+          <a:chExt cx="0" cy="0"/>
+        </a:xfrm>
+      </p:grpSpPr>
+      <p:sp>
+        <p:nvSpPr>
+          <p:cNvPr id="2" name="Slide Image Placeholder 1"/>
+          <p:cNvSpPr>
+            <a:spLocks noGrp="1" noRot="1" noChangeAspect="1"/>
+          </p:cNvSpPr>
+          <p:nvPr>
+            <p:ph type="sldImg"/>
+          </p:nvPr>
+        </p:nvSpPr>
+        <p:spPr/>
+      </p:sp>
+      <p:sp>
+        <p:nvSpPr>
+          <p:cNvPr id="3" name="Notes Placeholder 2"/>
+          <p:cNvSpPr>
+            <a:spLocks noGrp="1"/>
+          </p:cNvSpPr>
+          <p:nvPr>
+            <p:ph type="body" idx="1"/>
+          </p:nvPr>
+        </p:nvSpPr>
+        <p:spPr/>
+        <p:txBody>
+          <a:bodyPr/>
+          <a:lstStyle/>
+          <a:p>
+            <a:r>
+              <a:rPr lang="en-US" dirty="0"/>
+              <a:t>Close on the next step you would take with this team in the first two weeks.</a:t>
+            </a:r>
+            <a:endParaRPr lang="en-US" dirty="0"/>
+          </a:p>
+        </p:txBody>
+      </p:sp>
+      <p:sp>
+        <p:nvSpPr>
+          <p:cNvPr id="4" name="Slide Number Placeholder 3"/>
+          <p:cNvSpPr>
+            <a:spLocks noGrp="1"/>
+          </p:cNvSpPr>
+          <p:nvPr>
+            <p:ph type="sldNum" sz="quarter" idx="10"/>
+          </p:nvPr>
+        </p:nvSpPr>
+        <p:spPr/>
+        <p:txBody>
+          <a:bodyPr/>
+          <a:lstStyle/>
+          <a:p>
+            <a:fld id="{F7021451-1387-4CA6-816F-3879F97B5CBC}" type="slidenum">
+              <a:rPr lang="en-US"/>
+              <a:t>14</a:t>
             </a:fld>
             <a:endParaRPr lang="en-US"/>
           </a:p>
@@ -4718,6 +4807,512 @@
                 <a:ea typeface="Helvetica Neue" pitchFamily="34" charset="-122"/>
                 <a:cs typeface="Helvetica Neue" pitchFamily="34" charset="-120"/>
               </a:rPr>
+              <a:t>Meridian Navigator · Agent experience</a:t>
+            </a:r>
+            <a:endParaRPr lang="en-US" sz="1422" dirty="0"/>
+          </a:p>
+        </p:txBody>
+      </p:sp>
+      <p:sp>
+        <p:nvSpPr>
+          <p:cNvPr id="3" name="Text 1"/>
+          <p:cNvSpPr txBox="1"/>
+          <p:nvPr/>
+        </p:nvSpPr>
+        <p:spPr>
+          <a:xfrm>
+            <a:off x="457200" y="914400"/>
+            <a:ext cx="12070080" cy="594360"/>
+          </a:xfrm>
+          <a:prstGeom prst="rect">
+            <a:avLst/>
+          </a:prstGeom>
+          <a:noFill/>
+          <a:ln/>
+        </p:spPr>
+        <p:txBody>
+          <a:bodyPr wrap="square" lIns="0" tIns="0" rIns="0" bIns="0" rtlCol="0" anchor="t"/>
+          <a:lstStyle/>
+          <a:p>
+            <a:pPr indent="0" marL="0">
+              <a:buNone/>
+            </a:pPr>
+            <a:r>
+              <a:rPr lang="en-US" sz="3200" dirty="0">
+                <a:solidFill>
+                  <a:srgbClr val="1F1F1F"/>
+                </a:solidFill>
+                <a:latin typeface="Helvetica Neue Light" pitchFamily="34" charset="0"/>
+                <a:ea typeface="Helvetica Neue Light" pitchFamily="34" charset="-122"/>
+                <a:cs typeface="Helvetica Neue Light" pitchFamily="34" charset="-120"/>
+              </a:rPr>
+              <a:t>An AI that shows its reasoning and waits for approval</a:t>
+            </a:r>
+            <a:endParaRPr lang="en-US" sz="3200" dirty="0"/>
+          </a:p>
+        </p:txBody>
+      </p:sp>
+      <p:sp>
+        <p:nvSpPr>
+          <p:cNvPr id="4" name="Text 2"/>
+          <p:cNvSpPr txBox="1"/>
+          <p:nvPr/>
+        </p:nvSpPr>
+        <p:spPr>
+          <a:xfrm>
+            <a:off x="457200" y="1554480"/>
+            <a:ext cx="12070080" cy="365760"/>
+          </a:xfrm>
+          <a:prstGeom prst="rect">
+            <a:avLst/>
+          </a:prstGeom>
+          <a:noFill/>
+          <a:ln/>
+        </p:spPr>
+        <p:txBody>
+          <a:bodyPr wrap="square" lIns="0" tIns="0" rIns="0" bIns="0" rtlCol="0" anchor="t"/>
+          <a:lstStyle/>
+          <a:p>
+            <a:pPr indent="0" marL="0">
+              <a:buNone/>
+            </a:pPr>
+            <a:r>
+              <a:rPr lang="en-US" sz="1636" dirty="0">
+                <a:solidFill>
+                  <a:srgbClr val="595959"/>
+                </a:solidFill>
+                <a:latin typeface="Helvetica Neue Light" pitchFamily="34" charset="0"/>
+                <a:ea typeface="Helvetica Neue Light" pitchFamily="34" charset="-122"/>
+                <a:cs typeface="Helvetica Neue Light" pitchFamily="34" charset="-120"/>
+              </a:rPr>
+              <a:t>Adapt becomes a plan the user steers. Insight shows its evidence. Each order carries its reason. Mock data throughout.</a:t>
+            </a:r>
+            <a:endParaRPr lang="en-US" sz="1636" dirty="0"/>
+          </a:p>
+        </p:txBody>
+      </p:sp>
+      <p:pic>
+        <p:nvPicPr>
+          <p:cNvPr id="5" name="Image 0" descr="/tmp/meridian-deck/img/band-footer.png">    </p:cNvPr>
+          <p:cNvPicPr>
+            <a:picLocks noChangeAspect="1"/>
+          </p:cNvPicPr>
+          <p:nvPr/>
+        </p:nvPicPr>
+        <p:blipFill>
+          <a:blip r:embed="rId1"/>
+          <a:stretch>
+            <a:fillRect/>
+          </a:stretch>
+        </p:blipFill>
+        <p:spPr>
+          <a:xfrm>
+            <a:off x="0" y="9281160"/>
+            <a:ext cx="13004597" cy="466344"/>
+          </a:xfrm>
+          <a:prstGeom prst="rect">
+            <a:avLst/>
+          </a:prstGeom>
+        </p:spPr>
+      </p:pic>
+      <p:sp>
+        <p:nvSpPr>
+          <p:cNvPr id="7" name="Shape 3"/>
+          <p:cNvSpPr/>
+          <p:nvPr/>
+        </p:nvSpPr>
+        <p:spPr>
+          <a:xfrm>
+            <a:off x="457200" y="2560320"/>
+            <a:ext cx="12070080" cy="1828800"/>
+          </a:xfrm>
+          <a:prstGeom prst="rect">
+            <a:avLst/>
+          </a:prstGeom>
+          <a:solidFill>
+            <a:srgbClr val="FFFFFF"/>
+          </a:solidFill>
+          <a:ln w="12700">
+            <a:solidFill>
+              <a:srgbClr val="E2E2E2"/>
+            </a:solidFill>
+            <a:prstDash val="solid"/>
+          </a:ln>
+        </p:spPr>
+      </p:sp>
+      <p:sp>
+        <p:nvSpPr>
+          <p:cNvPr id="8" name="Text 4"/>
+          <p:cNvSpPr txBox="1"/>
+          <p:nvPr/>
+        </p:nvSpPr>
+        <p:spPr>
+          <a:xfrm>
+            <a:off x="731520" y="2761488"/>
+            <a:ext cx="11521440" cy="274320"/>
+          </a:xfrm>
+          <a:prstGeom prst="rect">
+            <a:avLst/>
+          </a:prstGeom>
+          <a:noFill/>
+          <a:ln/>
+        </p:spPr>
+        <p:txBody>
+          <a:bodyPr wrap="square" lIns="0" tIns="0" rIns="0" bIns="0" rtlCol="0" anchor="t"/>
+          <a:lstStyle/>
+          <a:p>
+            <a:pPr indent="0" marL="0">
+              <a:buNone/>
+            </a:pPr>
+            <a:r>
+              <a:rPr lang="en-US" sz="1280" b="1" spc="100" kern="0" dirty="0">
+                <a:solidFill>
+                  <a:srgbClr val="C45A35"/>
+                </a:solidFill>
+                <a:latin typeface="Helvetica Neue" pitchFamily="34" charset="0"/>
+                <a:ea typeface="Helvetica Neue" pitchFamily="34" charset="-122"/>
+                <a:cs typeface="Helvetica Neue" pitchFamily="34" charset="-120"/>
+              </a:rPr>
+              <a:t>PROBLEM</a:t>
+            </a:r>
+            <a:endParaRPr lang="en-US" sz="1280" dirty="0"/>
+          </a:p>
+        </p:txBody>
+      </p:sp>
+      <p:sp>
+        <p:nvSpPr>
+          <p:cNvPr id="9" name="Text 5"/>
+          <p:cNvSpPr txBox="1"/>
+          <p:nvPr/>
+        </p:nvSpPr>
+        <p:spPr>
+          <a:xfrm>
+            <a:off x="731520" y="3108960"/>
+            <a:ext cx="11521440" cy="1143000"/>
+          </a:xfrm>
+          <a:prstGeom prst="rect">
+            <a:avLst/>
+          </a:prstGeom>
+          <a:noFill/>
+          <a:ln/>
+        </p:spPr>
+        <p:txBody>
+          <a:bodyPr wrap="square" lIns="0" tIns="0" rIns="0" bIns="0" rtlCol="0" anchor="t"/>
+          <a:lstStyle/>
+          <a:p>
+            <a:pPr indent="0" marL="0">
+              <a:buNone/>
+            </a:pPr>
+            <a:r>
+              <a:rPr lang="en-US" sz="1700" dirty="0">
+                <a:solidFill>
+                  <a:srgbClr val="1F1F1F"/>
+                </a:solidFill>
+                <a:latin typeface="Helvetica Neue Light" pitchFamily="34" charset="0"/>
+                <a:ea typeface="Helvetica Neue Light" pitchFamily="34" charset="-122"/>
+                <a:cs typeface="Helvetica Neue Light" pitchFamily="34" charset="-120"/>
+              </a:rPr>
+              <a:t>Insight shows conclusions without evidence. Adapt is approve-or-dismiss for a batch of trades. Dismissals teach nothing. Orders lose their reason.</a:t>
+            </a:r>
+            <a:endParaRPr lang="en-US" sz="1700" dirty="0"/>
+          </a:p>
+        </p:txBody>
+      </p:sp>
+      <p:sp>
+        <p:nvSpPr>
+          <p:cNvPr id="10" name="Shape 6"/>
+          <p:cNvSpPr/>
+          <p:nvPr/>
+        </p:nvSpPr>
+        <p:spPr>
+          <a:xfrm>
+            <a:off x="457200" y="4663440"/>
+            <a:ext cx="12070080" cy="1828800"/>
+          </a:xfrm>
+          <a:prstGeom prst="rect">
+            <a:avLst/>
+          </a:prstGeom>
+          <a:solidFill>
+            <a:srgbClr val="FFFFFF"/>
+          </a:solidFill>
+          <a:ln w="12700">
+            <a:solidFill>
+              <a:srgbClr val="E2E2E2"/>
+            </a:solidFill>
+            <a:prstDash val="solid"/>
+          </a:ln>
+        </p:spPr>
+      </p:sp>
+      <p:sp>
+        <p:nvSpPr>
+          <p:cNvPr id="11" name="Text 7"/>
+          <p:cNvSpPr txBox="1"/>
+          <p:nvPr/>
+        </p:nvSpPr>
+        <p:spPr>
+          <a:xfrm>
+            <a:off x="731520" y="4864608"/>
+            <a:ext cx="11521440" cy="274320"/>
+          </a:xfrm>
+          <a:prstGeom prst="rect">
+            <a:avLst/>
+          </a:prstGeom>
+          <a:noFill/>
+          <a:ln/>
+        </p:spPr>
+        <p:txBody>
+          <a:bodyPr wrap="square" lIns="0" tIns="0" rIns="0" bIns="0" rtlCol="0" anchor="t"/>
+          <a:lstStyle/>
+          <a:p>
+            <a:pPr indent="0" marL="0">
+              <a:buNone/>
+            </a:pPr>
+            <a:r>
+              <a:rPr lang="en-US" sz="1280" b="1" spc="100" kern="0" dirty="0">
+                <a:solidFill>
+                  <a:srgbClr val="5B3F96"/>
+                </a:solidFill>
+                <a:latin typeface="Helvetica Neue" pitchFamily="34" charset="0"/>
+                <a:ea typeface="Helvetica Neue" pitchFamily="34" charset="-122"/>
+                <a:cs typeface="Helvetica Neue" pitchFamily="34" charset="-120"/>
+              </a:rPr>
+              <a:t>DECISION</a:t>
+            </a:r>
+            <a:endParaRPr lang="en-US" sz="1280" dirty="0"/>
+          </a:p>
+        </p:txBody>
+      </p:sp>
+      <p:sp>
+        <p:nvSpPr>
+          <p:cNvPr id="12" name="Text 8"/>
+          <p:cNvSpPr txBox="1"/>
+          <p:nvPr/>
+        </p:nvSpPr>
+        <p:spPr>
+          <a:xfrm>
+            <a:off x="731520" y="5212080"/>
+            <a:ext cx="11521440" cy="1143000"/>
+          </a:xfrm>
+          <a:prstGeom prst="rect">
+            <a:avLst/>
+          </a:prstGeom>
+          <a:noFill/>
+          <a:ln/>
+        </p:spPr>
+        <p:txBody>
+          <a:bodyPr wrap="square" lIns="0" tIns="0" rIns="0" bIns="0" rtlCol="0" anchor="t"/>
+          <a:lstStyle/>
+          <a:p>
+            <a:pPr indent="0" marL="0">
+              <a:buNone/>
+            </a:pPr>
+            <a:r>
+              <a:rPr lang="en-US" sz="1700" dirty="0">
+                <a:solidFill>
+                  <a:srgbClr val="1F1F1F"/>
+                </a:solidFill>
+                <a:latin typeface="Helvetica Neue Light" pitchFamily="34" charset="0"/>
+                <a:ea typeface="Helvetica Neue Light" pitchFamily="34" charset="-122"/>
+                <a:cs typeface="Helvetica Neue Light" pitchFamily="34" charset="-120"/>
+              </a:rPr>
+              <a:t>Goal to plan, with editable steps. Visible autonomy levels. Evidence on every output. Orders that carry their reason. A reviewable list of learned rules.</a:t>
+            </a:r>
+            <a:endParaRPr lang="en-US" sz="1700" dirty="0"/>
+          </a:p>
+        </p:txBody>
+      </p:sp>
+      <p:sp>
+        <p:nvSpPr>
+          <p:cNvPr id="13" name="Shape 9"/>
+          <p:cNvSpPr/>
+          <p:nvPr/>
+        </p:nvSpPr>
+        <p:spPr>
+          <a:xfrm>
+            <a:off x="457200" y="6766560"/>
+            <a:ext cx="12070080" cy="1828800"/>
+          </a:xfrm>
+          <a:prstGeom prst="rect">
+            <a:avLst/>
+          </a:prstGeom>
+          <a:solidFill>
+            <a:srgbClr val="FFFFFF"/>
+          </a:solidFill>
+          <a:ln w="12700">
+            <a:solidFill>
+              <a:srgbClr val="E2E2E2"/>
+            </a:solidFill>
+            <a:prstDash val="solid"/>
+          </a:ln>
+        </p:spPr>
+      </p:sp>
+      <p:sp>
+        <p:nvSpPr>
+          <p:cNvPr id="14" name="Text 10"/>
+          <p:cNvSpPr txBox="1"/>
+          <p:nvPr/>
+        </p:nvSpPr>
+        <p:spPr>
+          <a:xfrm>
+            <a:off x="731520" y="6967728"/>
+            <a:ext cx="11521440" cy="274320"/>
+          </a:xfrm>
+          <a:prstGeom prst="rect">
+            <a:avLst/>
+          </a:prstGeom>
+          <a:noFill/>
+          <a:ln/>
+        </p:spPr>
+        <p:txBody>
+          <a:bodyPr wrap="square" lIns="0" tIns="0" rIns="0" bIns="0" rtlCol="0" anchor="t"/>
+          <a:lstStyle/>
+          <a:p>
+            <a:pPr indent="0" marL="0">
+              <a:buNone/>
+            </a:pPr>
+            <a:r>
+              <a:rPr lang="en-US" sz="1280" b="1" spc="100" kern="0" dirty="0">
+                <a:solidFill>
+                  <a:srgbClr val="00868B"/>
+                </a:solidFill>
+                <a:latin typeface="Helvetica Neue" pitchFamily="34" charset="0"/>
+                <a:ea typeface="Helvetica Neue" pitchFamily="34" charset="-122"/>
+                <a:cs typeface="Helvetica Neue" pitchFamily="34" charset="-120"/>
+              </a:rPr>
+              <a:t>RESULT</a:t>
+            </a:r>
+            <a:endParaRPr lang="en-US" sz="1280" dirty="0"/>
+          </a:p>
+        </p:txBody>
+      </p:sp>
+      <p:sp>
+        <p:nvSpPr>
+          <p:cNvPr id="15" name="Text 11"/>
+          <p:cNvSpPr txBox="1"/>
+          <p:nvPr/>
+        </p:nvSpPr>
+        <p:spPr>
+          <a:xfrm>
+            <a:off x="731520" y="7315200"/>
+            <a:ext cx="11521440" cy="1143000"/>
+          </a:xfrm>
+          <a:prstGeom prst="rect">
+            <a:avLst/>
+          </a:prstGeom>
+          <a:noFill/>
+          <a:ln/>
+        </p:spPr>
+        <p:txBody>
+          <a:bodyPr wrap="square" lIns="0" tIns="0" rIns="0" bIns="0" rtlCol="0" anchor="t"/>
+          <a:lstStyle/>
+          <a:p>
+            <a:pPr indent="0" marL="0">
+              <a:buNone/>
+            </a:pPr>
+            <a:r>
+              <a:rPr lang="en-US" sz="1700" dirty="0">
+                <a:solidFill>
+                  <a:srgbClr val="1F1F1F"/>
+                </a:solidFill>
+                <a:latin typeface="Helvetica Neue Light" pitchFamily="34" charset="0"/>
+                <a:ea typeface="Helvetica Neue Light" pitchFamily="34" charset="-122"/>
+                <a:cs typeface="Helvetica Neue Light" pitchFamily="34" charset="-120"/>
+              </a:rPr>
+              <a:t>Clickable Figma wireframes for the plan, review, evidence and learned-rules flows. Effects are planned measures, not results.</a:t>
+            </a:r>
+            <a:endParaRPr lang="en-US" sz="1700" dirty="0"/>
+          </a:p>
+        </p:txBody>
+      </p:sp>
+      <p:pic>
+        <p:nvPicPr>
+          <p:cNvPr id="16" name="Image 1" descr="/tmp/meridian-deck/img/band-footer.png">    </p:cNvPr>
+          <p:cNvPicPr>
+            <a:picLocks noChangeAspect="1"/>
+          </p:cNvPicPr>
+          <p:nvPr/>
+        </p:nvPicPr>
+        <p:blipFill>
+          <a:blip r:embed="rId2"/>
+          <a:stretch>
+            <a:fillRect/>
+          </a:stretch>
+        </p:blipFill>
+        <p:spPr>
+          <a:xfrm>
+            <a:off x="0" y="9281160"/>
+            <a:ext cx="13004597" cy="466344"/>
+          </a:xfrm>
+          <a:prstGeom prst="rect">
+            <a:avLst/>
+          </a:prstGeom>
+        </p:spPr>
+      </p:pic>
+    </p:spTree>
+  </p:cSld>
+  <p:clrMapOvr>
+    <a:masterClrMapping/>
+  </p:clrMapOvr>
+</p:sld>
+</file>
+
+<file path=ppt/slides/slide14.xml><?xml version="1.0" encoding="utf-8"?>
+<p:sld xmlns:a="http://schemas.openxmlformats.org/drawingml/2006/main" xmlns:r="http://schemas.openxmlformats.org/officeDocument/2006/relationships" xmlns:p="http://schemas.openxmlformats.org/presentationml/2006/main">
+  <p:cSld name="Slide 14">
+    <p:bg>
+      <p:bgPr>
+        <a:solidFill>
+          <a:srgbClr val="FFFFFF"/>
+        </a:solidFill>
+      </p:bgPr>
+    </p:bg>
+    <p:spTree>
+      <p:nvGrpSpPr>
+        <p:cNvPr id="1" name=""/>
+        <p:cNvGrpSpPr/>
+        <p:nvPr/>
+      </p:nvGrpSpPr>
+      <p:grpSpPr>
+        <a:xfrm>
+          <a:off x="0" y="0"/>
+          <a:ext cx="0" cy="0"/>
+          <a:chOff x="0" y="0"/>
+          <a:chExt cx="0" cy="0"/>
+        </a:xfrm>
+      </p:grpSpPr>
+      <p:sp>
+        <p:nvSpPr>
+          <p:cNvPr id="2" name="Text 0"/>
+          <p:cNvSpPr txBox="1"/>
+          <p:nvPr/>
+        </p:nvSpPr>
+        <p:spPr>
+          <a:xfrm>
+            <a:off x="457200" y="393192"/>
+            <a:ext cx="10424160" cy="274320"/>
+          </a:xfrm>
+          <a:prstGeom prst="rect">
+            <a:avLst/>
+          </a:prstGeom>
+          <a:noFill/>
+          <a:ln/>
+        </p:spPr>
+        <p:txBody>
+          <a:bodyPr wrap="square" lIns="0" tIns="0" rIns="0" bIns="0" rtlCol="0" anchor="t"/>
+          <a:lstStyle/>
+          <a:p>
+            <a:pPr indent="0" marL="0">
+              <a:buNone/>
+            </a:pPr>
+            <a:r>
+              <a:rPr lang="en-US" sz="1422" dirty="0">
+                <a:solidFill>
+                  <a:srgbClr val="1F1F1F"/>
+                </a:solidFill>
+                <a:latin typeface="Helvetica Neue" pitchFamily="34" charset="0"/>
+                <a:ea typeface="Helvetica Neue" pitchFamily="34" charset="-122"/>
+                <a:cs typeface="Helvetica Neue" pitchFamily="34" charset="-120"/>
+              </a:rPr>
               <a:t>Next steps</a:t>
             </a:r>
             <a:endParaRPr lang="en-US" sz="1422" dirty="0"/>

</xml_diff>